<commit_message>
Remove obsolete animation and illustration files: deleted feedback loops, prior frameworks, test animations, and yogurt illustration images to clean up the output directory.
</commit_message>
<xml_diff>
--- a/output/LLM_Self_Correction_ICLR2024_Group_Presentation-final.pptx
+++ b/output/LLM_Self_Correction_ICLR2024_Group_Presentation-final.pptx
@@ -342,6 +342,9 @@
                 </c:pt>
                 <c:pt idx="1">
                   <c:v>-1.5</c:v>
+                </c:pt>
+                <c:pt idx="2">
+                  <c:v>0</c:v>
                 </c:pt>
               </c:numCache>
             </c:numRef>
@@ -33237,7 +33240,7 @@
               <a:buNone/>
             </a:pPr>
             <a:r>
-              <a:rPr lang="en-US" sz="1000" dirty="0">
+              <a:rPr lang="en-US" sz="900" dirty="0">
                 <a:solidFill>
                   <a:srgbClr val="64748B"/>
                 </a:solidFill>
@@ -33247,7 +33250,7 @@
               </a:rPr>
               <a:t>Frozen Weights</a:t>
             </a:r>
-            <a:endParaRPr lang="en-US" sz="1000" dirty="0"/>
+            <a:endParaRPr lang="en-US" sz="900" dirty="0"/>
           </a:p>
         </p:txBody>
       </p:sp>
@@ -34611,7 +34614,7 @@
           <p:nvPr>
             <p:extLst>
               <p:ext uri="{D42A27DB-BD31-4B8C-83A1-F6EECF244321}">
-                <p14:modId xmlns:p14="http://schemas.microsoft.com/office/powerpoint/2010/main" val="3137005941"/>
+                <p14:modId xmlns:p14="http://schemas.microsoft.com/office/powerpoint/2010/main" val="2353136879"/>
               </p:ext>
             </p:extLst>
           </p:nvPr>

</xml_diff>

<commit_message>
Update presentation materials: revise the Self-Refine description in the speech scripts to clarify the use of structured feedback checklists, and update the Bangla explanation accordingly. Ensure consistency across all related documents.
</commit_message>
<xml_diff>
--- a/output/LLM_Self_Correction_ICLR2024_Group_Presentation-final.pptx
+++ b/output/LLM_Self_Correction_ICLR2024_Group_Presentation-final.pptx
@@ -4079,9 +4079,395 @@
           <a:lstStyle/>
           <a:p>
             <a:r>
+              <a:rPr lang="en-US" sz="1200" b="0" i="0" kern="1200" dirty="0">
+                <a:solidFill>
+                  <a:schemeClr val="tx1"/>
+                </a:solidFill>
+                <a:effectLst/>
+                <a:latin typeface="+mn-lt"/>
+                <a:ea typeface="+mn-ea"/>
+                <a:cs typeface="+mn-cs"/>
+              </a:rPr>
+              <a:t>Thank you, </a:t>
+            </a:r>
+            <a:r>
+              <a:rPr lang="en-US" sz="1200" b="0" i="0" kern="1200" dirty="0" err="1">
+                <a:solidFill>
+                  <a:schemeClr val="tx1"/>
+                </a:solidFill>
+                <a:effectLst/>
+                <a:latin typeface="+mn-lt"/>
+                <a:ea typeface="+mn-ea"/>
+                <a:cs typeface="+mn-cs"/>
+              </a:rPr>
+              <a:t>Srijon</a:t>
+            </a:r>
+            <a:r>
+              <a:rPr lang="en-US" sz="1200" b="0" i="0" kern="1200" dirty="0">
+                <a:solidFill>
+                  <a:schemeClr val="tx1"/>
+                </a:solidFill>
+                <a:effectLst/>
+                <a:latin typeface="+mn-lt"/>
+                <a:ea typeface="+mn-ea"/>
+                <a:cs typeface="+mn-cs"/>
+              </a:rPr>
+              <a:t>. I will now examine the prior literature and why earlier claims looked so convincing on paper.</a:t>
+            </a:r>
+          </a:p>
+          <a:p>
+            <a:endParaRPr lang="en-US" sz="1200" b="0" i="1" kern="1200" dirty="0">
+              <a:solidFill>
+                <a:schemeClr val="tx1"/>
+              </a:solidFill>
+              <a:effectLst/>
+              <a:latin typeface="+mn-lt"/>
+              <a:ea typeface="+mn-ea"/>
+              <a:cs typeface="+mn-cs"/>
+            </a:endParaRPr>
+          </a:p>
+          <a:p>
+            <a:r>
+              <a:rPr lang="en-US" sz="1200" b="0" i="1" kern="1200" dirty="0">
+                <a:solidFill>
+                  <a:schemeClr val="tx1"/>
+                </a:solidFill>
+                <a:effectLst/>
+                <a:latin typeface="+mn-lt"/>
+                <a:ea typeface="+mn-ea"/>
+                <a:cs typeface="+mn-cs"/>
+              </a:rPr>
+              <a:t>"If you followed AI research throughout 2023, it felt like every quarter brought a shiny new framework claiming language models could fix their own mistakes. It was the same excitement we see today whenever rumors drop about unreleased models like Fable 5.1 or secret codenames. Everyone wanted to believe that self-correction was a solved problem."</a:t>
+            </a:r>
+          </a:p>
+          <a:p>
+            <a:endParaRPr lang="en-US" sz="1200" b="0" i="1" kern="1200" dirty="0">
+              <a:solidFill>
+                <a:schemeClr val="tx1"/>
+              </a:solidFill>
+              <a:effectLst/>
+              <a:latin typeface="+mn-lt"/>
+              <a:ea typeface="+mn-ea"/>
+              <a:cs typeface="+mn-cs"/>
+            </a:endParaRPr>
+          </a:p>
+          <a:p>
+            <a:r>
+              <a:rPr lang="en-US" sz="1200" b="0" i="0" kern="1200" dirty="0">
+                <a:solidFill>
+                  <a:schemeClr val="tx1"/>
+                </a:solidFill>
+                <a:effectLst/>
+                <a:latin typeface="+mn-lt"/>
+                <a:ea typeface="+mn-ea"/>
+                <a:cs typeface="+mn-cs"/>
+              </a:rPr>
+              <a:t>Look at the four timeline cards across 2023 on our slide.</a:t>
+            </a:r>
+          </a:p>
+          <a:p>
+            <a:r>
+              <a:rPr lang="en-US" sz="1200" b="0" i="0" kern="1200" dirty="0">
+                <a:solidFill>
+                  <a:schemeClr val="tx1"/>
+                </a:solidFill>
+                <a:effectLst/>
+                <a:latin typeface="+mn-lt"/>
+                <a:ea typeface="+mn-ea"/>
+                <a:cs typeface="+mn-cs"/>
+              </a:rPr>
+              <a:t>In Q1, Kim and colleagues published </a:t>
+            </a:r>
+            <a:r>
+              <a:rPr lang="en-US" sz="1200" b="1" i="0" kern="1200" dirty="0">
+                <a:solidFill>
+                  <a:schemeClr val="tx1"/>
+                </a:solidFill>
+                <a:effectLst/>
+                <a:latin typeface="+mn-lt"/>
+                <a:ea typeface="+mn-ea"/>
+                <a:cs typeface="+mn-cs"/>
+              </a:rPr>
+              <a:t>RCI</a:t>
+            </a:r>
+            <a:r>
+              <a:rPr lang="en-US" sz="1200" b="0" i="0" kern="1200" dirty="0">
+                <a:solidFill>
+                  <a:schemeClr val="tx1"/>
+                </a:solidFill>
+                <a:effectLst/>
+                <a:latin typeface="+mn-lt"/>
+                <a:ea typeface="+mn-ea"/>
+                <a:cs typeface="+mn-cs"/>
+              </a:rPr>
+              <a:t>, claiming a 7% boost on math and reasoning by prompting the model to recursively critique its own code.</a:t>
+            </a:r>
+          </a:p>
+          <a:p>
+            <a:r>
+              <a:rPr lang="en-US" sz="1200" b="0" i="0" kern="1200" dirty="0">
+                <a:solidFill>
+                  <a:schemeClr val="tx1"/>
+                </a:solidFill>
+                <a:effectLst/>
+                <a:latin typeface="+mn-lt"/>
+                <a:ea typeface="+mn-ea"/>
+                <a:cs typeface="+mn-cs"/>
+              </a:rPr>
+              <a:t>In Q2, Shinn and colleagues introduced </a:t>
+            </a:r>
+            <a:r>
+              <a:rPr lang="en-US" sz="1200" b="1" i="0" kern="1200" dirty="0" err="1">
+                <a:solidFill>
+                  <a:schemeClr val="tx1"/>
+                </a:solidFill>
+                <a:effectLst/>
+                <a:latin typeface="+mn-lt"/>
+                <a:ea typeface="+mn-ea"/>
+                <a:cs typeface="+mn-cs"/>
+              </a:rPr>
+              <a:t>Reflexion</a:t>
+            </a:r>
+            <a:r>
+              <a:rPr lang="en-US" sz="1200" b="0" i="0" kern="1200" dirty="0">
+                <a:solidFill>
+                  <a:schemeClr val="tx1"/>
+                </a:solidFill>
+                <a:effectLst/>
+                <a:latin typeface="+mn-lt"/>
+                <a:ea typeface="+mn-ea"/>
+                <a:cs typeface="+mn-cs"/>
+              </a:rPr>
+              <a:t>, claiming an 11% improvement by storing verbal reflections across multiple trials.</a:t>
+            </a:r>
+          </a:p>
+          <a:p>
+            <a:r>
+              <a:rPr lang="en-US" sz="1200" b="0" i="0" kern="1200" dirty="0">
+                <a:solidFill>
+                  <a:schemeClr val="tx1"/>
+                </a:solidFill>
+                <a:effectLst/>
+                <a:latin typeface="+mn-lt"/>
+                <a:ea typeface="+mn-ea"/>
+                <a:cs typeface="+mn-cs"/>
+              </a:rPr>
+              <a:t>In Q3, Madaan and colleagues introduced </a:t>
+            </a:r>
+            <a:r>
+              <a:rPr lang="en-US" sz="1200" b="1" i="0" kern="1200" dirty="0">
+                <a:solidFill>
+                  <a:schemeClr val="tx1"/>
+                </a:solidFill>
+                <a:effectLst/>
+                <a:latin typeface="+mn-lt"/>
+                <a:ea typeface="+mn-ea"/>
+                <a:cs typeface="+mn-cs"/>
+              </a:rPr>
+              <a:t>Self-Refine</a:t>
+            </a:r>
+            <a:r>
+              <a:rPr lang="en-US" sz="1200" b="0" i="0" kern="1200" dirty="0">
+                <a:solidFill>
+                  <a:schemeClr val="tx1"/>
+                </a:solidFill>
+                <a:effectLst/>
+                <a:latin typeface="+mn-lt"/>
+                <a:ea typeface="+mn-ea"/>
+                <a:cs typeface="+mn-cs"/>
+              </a:rPr>
+              <a:t>, reporting a 10% gain using structured feedback checklists.</a:t>
+            </a:r>
+          </a:p>
+          <a:p>
+            <a:r>
+              <a:rPr lang="en-US" sz="1200" b="0" i="0" kern="1200" dirty="0">
+                <a:solidFill>
+                  <a:schemeClr val="tx1"/>
+                </a:solidFill>
+                <a:effectLst/>
+                <a:latin typeface="+mn-lt"/>
+                <a:ea typeface="+mn-ea"/>
+                <a:cs typeface="+mn-cs"/>
+              </a:rPr>
+              <a:t>And in Q4, Du and colleagues claimed </a:t>
+            </a:r>
+            <a:r>
+              <a:rPr lang="en-US" sz="1200" b="1" i="0" kern="1200" dirty="0">
+                <a:solidFill>
+                  <a:schemeClr val="tx1"/>
+                </a:solidFill>
+                <a:effectLst/>
+                <a:latin typeface="+mn-lt"/>
+                <a:ea typeface="+mn-ea"/>
+                <a:cs typeface="+mn-cs"/>
+              </a:rPr>
+              <a:t>Multi-Agent Debate</a:t>
+            </a:r>
+            <a:r>
+              <a:rPr lang="en-US" sz="1200" b="0" i="0" kern="1200" dirty="0">
+                <a:solidFill>
+                  <a:schemeClr val="tx1"/>
+                </a:solidFill>
+                <a:effectLst/>
+                <a:latin typeface="+mn-lt"/>
+                <a:ea typeface="+mn-ea"/>
+                <a:cs typeface="+mn-cs"/>
+              </a:rPr>
+              <a:t> gave another 4% boost by having multiple instances debate divergent answers.</a:t>
+            </a:r>
+          </a:p>
+          <a:p>
+            <a:endParaRPr lang="en-US" sz="1200" b="0" i="0" kern="1200" dirty="0">
+              <a:solidFill>
+                <a:schemeClr val="tx1"/>
+              </a:solidFill>
+              <a:effectLst/>
+              <a:latin typeface="+mn-lt"/>
+              <a:ea typeface="+mn-ea"/>
+              <a:cs typeface="+mn-cs"/>
+            </a:endParaRPr>
+          </a:p>
+          <a:p>
+            <a:r>
+              <a:rPr lang="en-US" sz="1200" b="0" i="0" kern="1200" dirty="0">
+                <a:solidFill>
+                  <a:schemeClr val="tx1"/>
+                </a:solidFill>
+                <a:effectLst/>
+                <a:latin typeface="+mn-lt"/>
+                <a:ea typeface="+mn-ea"/>
+                <a:cs typeface="+mn-cs"/>
+              </a:rPr>
+              <a:t>On the surface, these numbers looked great. But look at the callout at the bottom of the slide: </a:t>
+            </a:r>
+            <a:r>
+              <a:rPr lang="en-US" sz="1200" b="1" i="0" kern="1200" dirty="0">
+                <a:solidFill>
+                  <a:schemeClr val="tx1"/>
+                </a:solidFill>
+                <a:effectLst/>
+                <a:latin typeface="+mn-lt"/>
+                <a:ea typeface="+mn-ea"/>
+                <a:cs typeface="+mn-cs"/>
+              </a:rPr>
+              <a:t>what the timeline hides</a:t>
+            </a:r>
+            <a:r>
+              <a:rPr lang="en-US" sz="1200" b="0" i="0" kern="1200" dirty="0">
+                <a:solidFill>
+                  <a:schemeClr val="tx1"/>
+                </a:solidFill>
+                <a:effectLst/>
+                <a:latin typeface="+mn-lt"/>
+                <a:ea typeface="+mn-ea"/>
+                <a:cs typeface="+mn-cs"/>
+              </a:rPr>
+              <a:t>.</a:t>
+            </a:r>
+          </a:p>
+          <a:p>
+            <a:endParaRPr lang="en-US" sz="1200" b="0" i="0" kern="1200" dirty="0">
+              <a:solidFill>
+                <a:schemeClr val="tx1"/>
+              </a:solidFill>
+              <a:effectLst/>
+              <a:latin typeface="+mn-lt"/>
+              <a:ea typeface="+mn-ea"/>
+              <a:cs typeface="+mn-cs"/>
+            </a:endParaRPr>
+          </a:p>
+          <a:p>
+            <a:r>
+              <a:rPr lang="en-US" sz="1200" b="0" i="0" kern="1200" dirty="0">
+                <a:solidFill>
+                  <a:schemeClr val="tx1"/>
+                </a:solidFill>
+                <a:effectLst/>
+                <a:latin typeface="+mn-lt"/>
+                <a:ea typeface="+mn-ea"/>
+                <a:cs typeface="+mn-cs"/>
+              </a:rPr>
+              <a:t>When you inspect the experimental setups, none of these gains came from intrinsic self-correction. Both RCI and </a:t>
+            </a:r>
+            <a:r>
+              <a:rPr lang="en-US" sz="1200" b="0" i="0" kern="1200" dirty="0" err="1">
+                <a:solidFill>
+                  <a:schemeClr val="tx1"/>
+                </a:solidFill>
+                <a:effectLst/>
+                <a:latin typeface="+mn-lt"/>
+                <a:ea typeface="+mn-ea"/>
+                <a:cs typeface="+mn-cs"/>
+              </a:rPr>
+              <a:t>Reflexion</a:t>
+            </a:r>
+            <a:r>
+              <a:rPr lang="en-US" sz="1200" b="0" i="0" kern="1200" dirty="0">
+                <a:solidFill>
+                  <a:schemeClr val="tx1"/>
+                </a:solidFill>
+                <a:effectLst/>
+                <a:latin typeface="+mn-lt"/>
+                <a:ea typeface="+mn-ea"/>
+                <a:cs typeface="+mn-cs"/>
+              </a:rPr>
+              <a:t> relied on </a:t>
+            </a:r>
+            <a:r>
+              <a:rPr lang="en-US" sz="1200" b="1" i="0" kern="1200" dirty="0">
+                <a:solidFill>
+                  <a:schemeClr val="tx1"/>
+                </a:solidFill>
+                <a:effectLst/>
+                <a:latin typeface="+mn-lt"/>
+                <a:ea typeface="+mn-ea"/>
+                <a:cs typeface="+mn-cs"/>
+              </a:rPr>
+              <a:t>oracle leakage</a:t>
+            </a:r>
+            <a:r>
+              <a:rPr lang="en-US" sz="1200" b="0" i="0" kern="1200" dirty="0">
+                <a:solidFill>
+                  <a:schemeClr val="tx1"/>
+                </a:solidFill>
+                <a:effectLst/>
+                <a:latin typeface="+mn-lt"/>
+                <a:ea typeface="+mn-ea"/>
+                <a:cs typeface="+mn-cs"/>
+              </a:rPr>
+              <a:t>, meaning the test harness secretly told the model when it got an answer wrong. Self-Refine relied on a </a:t>
+            </a:r>
+            <a:r>
+              <a:rPr lang="en-US" sz="1200" b="1" i="0" kern="1200" dirty="0">
+                <a:solidFill>
+                  <a:schemeClr val="tx1"/>
+                </a:solidFill>
+                <a:effectLst/>
+                <a:latin typeface="+mn-lt"/>
+                <a:ea typeface="+mn-ea"/>
+                <a:cs typeface="+mn-cs"/>
+              </a:rPr>
+              <a:t>prompt trick</a:t>
+            </a:r>
+            <a:r>
+              <a:rPr lang="en-US" sz="1200" b="0" i="0" kern="1200" dirty="0">
+                <a:solidFill>
+                  <a:schemeClr val="tx1"/>
+                </a:solidFill>
+                <a:effectLst/>
+                <a:latin typeface="+mn-lt"/>
+                <a:ea typeface="+mn-ea"/>
+                <a:cs typeface="+mn-cs"/>
+              </a:rPr>
+              <a:t>, where rules were omitted in the initial prompt and only provided during feedback. And Multi-Agent Debate simply burned three to six times more compute.</a:t>
+            </a:r>
+          </a:p>
+          <a:p>
+            <a:br>
               <a:rPr lang="en-US" dirty="0"/>
-              <a:t>Speaker: Srijon reviews the four prior self-correction frameworks and their operational loops, highlighting that reported gains stemmed from evaluation confounders.</a:t>
-            </a:r>
+            </a:br>
+            <a:endParaRPr lang="en-US" dirty="0"/>
           </a:p>
         </p:txBody>
       </p:sp>
@@ -4184,8 +4570,299 @@
           <a:lstStyle/>
           <a:p>
             <a:r>
-              <a:rPr lang="en-US" dirty="0"/>
-              <a:t>Speaker: Srijon reviews the four prior self-correction frameworks and their operational loops, highlighting that reported gains stemmed from evaluation confounders.</a:t>
+              <a:rPr lang="en-US" sz="1200" b="0" i="0" kern="1200" dirty="0">
+                <a:solidFill>
+                  <a:schemeClr val="tx1"/>
+                </a:solidFill>
+                <a:effectLst/>
+                <a:latin typeface="+mn-lt"/>
+                <a:ea typeface="+mn-ea"/>
+                <a:cs typeface="+mn-cs"/>
+              </a:rPr>
+              <a:t>This slide illustrates the core distinction that prior literature often conflated: a </a:t>
+            </a:r>
+            <a:r>
+              <a:rPr lang="en-US" sz="1200" b="1" i="0" kern="1200" dirty="0">
+                <a:solidFill>
+                  <a:schemeClr val="tx1"/>
+                </a:solidFill>
+                <a:effectLst/>
+                <a:latin typeface="+mn-lt"/>
+                <a:ea typeface="+mn-ea"/>
+                <a:cs typeface="+mn-cs"/>
+              </a:rPr>
+              <a:t>closed loop</a:t>
+            </a:r>
+            <a:r>
+              <a:rPr lang="en-US" sz="1200" b="0" i="0" kern="1200" dirty="0">
+                <a:solidFill>
+                  <a:schemeClr val="tx1"/>
+                </a:solidFill>
+                <a:effectLst/>
+                <a:latin typeface="+mn-lt"/>
+                <a:ea typeface="+mn-ea"/>
+                <a:cs typeface="+mn-cs"/>
+              </a:rPr>
+              <a:t> versus a </a:t>
+            </a:r>
+            <a:r>
+              <a:rPr lang="en-US" sz="1200" b="1" i="0" kern="1200" dirty="0">
+                <a:solidFill>
+                  <a:schemeClr val="tx1"/>
+                </a:solidFill>
+                <a:effectLst/>
+                <a:latin typeface="+mn-lt"/>
+                <a:ea typeface="+mn-ea"/>
+                <a:cs typeface="+mn-cs"/>
+              </a:rPr>
+              <a:t>grounded loop</a:t>
+            </a:r>
+            <a:r>
+              <a:rPr lang="en-US" sz="1200" b="0" i="0" kern="1200" dirty="0">
+                <a:solidFill>
+                  <a:schemeClr val="tx1"/>
+                </a:solidFill>
+                <a:effectLst/>
+                <a:latin typeface="+mn-lt"/>
+                <a:ea typeface="+mn-ea"/>
+                <a:cs typeface="+mn-cs"/>
+              </a:rPr>
+              <a:t>.</a:t>
+            </a:r>
+          </a:p>
+          <a:p>
+            <a:endParaRPr lang="en-US" sz="1200" b="0" i="0" kern="1200" dirty="0">
+              <a:solidFill>
+                <a:schemeClr val="tx1"/>
+              </a:solidFill>
+              <a:effectLst/>
+              <a:latin typeface="+mn-lt"/>
+              <a:ea typeface="+mn-ea"/>
+              <a:cs typeface="+mn-cs"/>
+            </a:endParaRPr>
+          </a:p>
+          <a:p>
+            <a:r>
+              <a:rPr lang="en-US" sz="1200" b="0" i="0" kern="1200" dirty="0">
+                <a:solidFill>
+                  <a:schemeClr val="tx1"/>
+                </a:solidFill>
+                <a:effectLst/>
+                <a:latin typeface="+mn-lt"/>
+                <a:ea typeface="+mn-ea"/>
+                <a:cs typeface="+mn-cs"/>
+              </a:rPr>
+              <a:t>Look at the red box on the left. This is the </a:t>
+            </a:r>
+            <a:r>
+              <a:rPr lang="en-US" sz="1200" b="1" i="0" kern="1200" dirty="0">
+                <a:solidFill>
+                  <a:schemeClr val="tx1"/>
+                </a:solidFill>
+                <a:effectLst/>
+                <a:latin typeface="+mn-lt"/>
+                <a:ea typeface="+mn-ea"/>
+                <a:cs typeface="+mn-cs"/>
+              </a:rPr>
+              <a:t>closed loop</a:t>
+            </a:r>
+            <a:r>
+              <a:rPr lang="en-US" sz="1200" b="0" i="0" kern="1200" dirty="0">
+                <a:solidFill>
+                  <a:schemeClr val="tx1"/>
+                </a:solidFill>
+                <a:effectLst/>
+                <a:latin typeface="+mn-lt"/>
+                <a:ea typeface="+mn-ea"/>
+                <a:cs typeface="+mn-cs"/>
+              </a:rPr>
+              <a:t>, which is the exact focus of our paper. The model generates an initial answer, receives an unguided prompt to find flaws, and attempts a blind revision.</a:t>
+            </a:r>
+          </a:p>
+          <a:p>
+            <a:endParaRPr lang="en-US" sz="1200" b="0" i="0" kern="1200" dirty="0">
+              <a:solidFill>
+                <a:schemeClr val="tx1"/>
+              </a:solidFill>
+              <a:effectLst/>
+              <a:latin typeface="+mn-lt"/>
+              <a:ea typeface="+mn-ea"/>
+              <a:cs typeface="+mn-cs"/>
+            </a:endParaRPr>
+          </a:p>
+          <a:p>
+            <a:r>
+              <a:rPr lang="en-US" sz="1200" b="0" i="0" kern="1200" dirty="0">
+                <a:solidFill>
+                  <a:schemeClr val="tx1"/>
+                </a:solidFill>
+                <a:effectLst/>
+                <a:latin typeface="+mn-lt"/>
+                <a:ea typeface="+mn-ea"/>
+                <a:cs typeface="+mn-cs"/>
+              </a:rPr>
+              <a:t>Notice the fundamental flaw: zero new information enters the system. The weights of the model are frozen. You are asking the exact same network that made the error to spot its own error.</a:t>
+            </a:r>
+          </a:p>
+          <a:p>
+            <a:endParaRPr lang="en-US" sz="1200" b="0" i="1" kern="1200" dirty="0">
+              <a:solidFill>
+                <a:schemeClr val="tx1"/>
+              </a:solidFill>
+              <a:effectLst/>
+              <a:latin typeface="+mn-lt"/>
+              <a:ea typeface="+mn-ea"/>
+              <a:cs typeface="+mn-cs"/>
+            </a:endParaRPr>
+          </a:p>
+          <a:p>
+            <a:r>
+              <a:rPr lang="en-US" sz="1200" b="0" i="1" kern="1200" dirty="0">
+                <a:solidFill>
+                  <a:schemeClr val="tx1"/>
+                </a:solidFill>
+                <a:effectLst/>
+                <a:latin typeface="+mn-lt"/>
+                <a:ea typeface="+mn-ea"/>
+                <a:cs typeface="+mn-cs"/>
+              </a:rPr>
+              <a:t>"Anyone who has experimented with language models knows what happens next. If you ask an LLM, 'Are you sure about that?', it immediately panics, apologizes for a mistake it never made, and turns a correct answer into a completely broken one."</a:t>
+            </a:r>
+          </a:p>
+          <a:p>
+            <a:r>
+              <a:rPr lang="en-US" sz="1200" b="0" i="0" kern="1200" dirty="0">
+                <a:solidFill>
+                  <a:schemeClr val="tx1"/>
+                </a:solidFill>
+                <a:effectLst/>
+                <a:latin typeface="+mn-lt"/>
+                <a:ea typeface="+mn-ea"/>
+                <a:cs typeface="+mn-cs"/>
+              </a:rPr>
+              <a:t>Because of this compliance bias and lack of external truth, intrinsic self-correction consistently decreases accuracy by </a:t>
+            </a:r>
+            <a:r>
+              <a:rPr lang="en-US" sz="1200" b="1" i="0" kern="1200" dirty="0">
+                <a:solidFill>
+                  <a:schemeClr val="tx1"/>
+                </a:solidFill>
+                <a:effectLst/>
+                <a:latin typeface="+mn-lt"/>
+                <a:ea typeface="+mn-ea"/>
+                <a:cs typeface="+mn-cs"/>
+              </a:rPr>
+              <a:t>1.3% to 27.5%</a:t>
+            </a:r>
+            <a:r>
+              <a:rPr lang="en-US" sz="1200" b="0" i="0" kern="1200" dirty="0">
+                <a:solidFill>
+                  <a:schemeClr val="tx1"/>
+                </a:solidFill>
+                <a:effectLst/>
+                <a:latin typeface="+mn-lt"/>
+                <a:ea typeface="+mn-ea"/>
+                <a:cs typeface="+mn-cs"/>
+              </a:rPr>
+              <a:t>.</a:t>
+            </a:r>
+          </a:p>
+          <a:p>
+            <a:endParaRPr lang="en-US" sz="1200" b="0" i="0" kern="1200" dirty="0">
+              <a:solidFill>
+                <a:schemeClr val="tx1"/>
+              </a:solidFill>
+              <a:effectLst/>
+              <a:latin typeface="+mn-lt"/>
+              <a:ea typeface="+mn-ea"/>
+              <a:cs typeface="+mn-cs"/>
+            </a:endParaRPr>
+          </a:p>
+          <a:p>
+            <a:r>
+              <a:rPr lang="en-US" sz="1200" b="0" i="0" kern="1200" dirty="0">
+                <a:solidFill>
+                  <a:schemeClr val="tx1"/>
+                </a:solidFill>
+                <a:effectLst/>
+                <a:latin typeface="+mn-lt"/>
+                <a:ea typeface="+mn-ea"/>
+                <a:cs typeface="+mn-cs"/>
+              </a:rPr>
+              <a:t>Now look at the green box on the right. This is the </a:t>
+            </a:r>
+            <a:r>
+              <a:rPr lang="en-US" sz="1200" b="1" i="0" kern="1200" dirty="0">
+                <a:solidFill>
+                  <a:schemeClr val="tx1"/>
+                </a:solidFill>
+                <a:effectLst/>
+                <a:latin typeface="+mn-lt"/>
+                <a:ea typeface="+mn-ea"/>
+                <a:cs typeface="+mn-cs"/>
+              </a:rPr>
+              <a:t>grounded loop</a:t>
+            </a:r>
+            <a:r>
+              <a:rPr lang="en-US" sz="1200" b="0" i="0" kern="1200" dirty="0">
+                <a:solidFill>
+                  <a:schemeClr val="tx1"/>
+                </a:solidFill>
+                <a:effectLst/>
+                <a:latin typeface="+mn-lt"/>
+                <a:ea typeface="+mn-ea"/>
+                <a:cs typeface="+mn-cs"/>
+              </a:rPr>
+              <a:t>, and this is where self-correction genuinely works.</a:t>
+            </a:r>
+          </a:p>
+          <a:p>
+            <a:endParaRPr lang="en-US" sz="1200" b="0" i="0" kern="1200" dirty="0">
+              <a:solidFill>
+                <a:schemeClr val="tx1"/>
+              </a:solidFill>
+              <a:effectLst/>
+              <a:latin typeface="+mn-lt"/>
+              <a:ea typeface="+mn-ea"/>
+              <a:cs typeface="+mn-cs"/>
+            </a:endParaRPr>
+          </a:p>
+          <a:p>
+            <a:r>
+              <a:rPr lang="en-US" sz="1200" b="0" i="0" kern="1200" dirty="0">
+                <a:solidFill>
+                  <a:schemeClr val="tx1"/>
+                </a:solidFill>
+                <a:effectLst/>
+                <a:latin typeface="+mn-lt"/>
+                <a:ea typeface="+mn-ea"/>
+                <a:cs typeface="+mn-cs"/>
+              </a:rPr>
+              <a:t>Here, the model writes executable code or equations and runs them in a deterministic environment like a Python interpreter. When the execution fails with an exact traceback, the model conditions its update on objective ground truth. That produces real gains between </a:t>
+            </a:r>
+            <a:r>
+              <a:rPr lang="en-US" sz="1200" b="1" i="0" kern="1200" dirty="0">
+                <a:solidFill>
+                  <a:schemeClr val="tx1"/>
+                </a:solidFill>
+                <a:effectLst/>
+                <a:latin typeface="+mn-lt"/>
+                <a:ea typeface="+mn-ea"/>
+                <a:cs typeface="+mn-cs"/>
+              </a:rPr>
+              <a:t>7% and 15%</a:t>
+            </a:r>
+            <a:r>
+              <a:rPr lang="en-US" sz="1200" b="0" i="0" kern="1200" dirty="0">
+                <a:solidFill>
+                  <a:schemeClr val="tx1"/>
+                </a:solidFill>
+                <a:effectLst/>
+                <a:latin typeface="+mn-lt"/>
+                <a:ea typeface="+mn-ea"/>
+                <a:cs typeface="+mn-cs"/>
+              </a:rPr>
+              <a:t>.</a:t>
             </a:r>
           </a:p>
         </p:txBody>
@@ -4295,8 +4972,265 @@
           <a:lstStyle/>
           <a:p>
             <a:r>
-              <a:rPr lang="en-US" dirty="0"/>
-              <a:t>Speaker: Srijon reviews the four prior self-correction frameworks and their operational loops, highlighting that reported gains stemmed from evaluation confounders.</a:t>
+              <a:rPr lang="en-US" sz="1200" b="0" i="0" kern="1200" dirty="0">
+                <a:solidFill>
+                  <a:schemeClr val="tx1"/>
+                </a:solidFill>
+                <a:effectLst/>
+                <a:latin typeface="+mn-lt"/>
+                <a:ea typeface="+mn-ea"/>
+                <a:cs typeface="+mn-cs"/>
+              </a:rPr>
+              <a:t>On this slide, we present the forensic breakdown of prior claims.</a:t>
+            </a:r>
+          </a:p>
+          <a:p>
+            <a:r>
+              <a:rPr lang="en-US" sz="1200" b="0" i="0" kern="1200" dirty="0">
+                <a:solidFill>
+                  <a:schemeClr val="tx1"/>
+                </a:solidFill>
+                <a:effectLst/>
+                <a:latin typeface="+mn-lt"/>
+                <a:ea typeface="+mn-ea"/>
+                <a:cs typeface="+mn-cs"/>
+              </a:rPr>
+              <a:t>Look at the paired bar chart on the left. The red bars represent the claimed accuracy improvements from earlier literature. The green bars represent what happens when you run a controlled, scientifically rigorous test.</a:t>
+            </a:r>
+          </a:p>
+          <a:p>
+            <a:endParaRPr lang="en-US" sz="1200" b="0" i="0" kern="1200" dirty="0">
+              <a:solidFill>
+                <a:schemeClr val="tx1"/>
+              </a:solidFill>
+              <a:effectLst/>
+              <a:latin typeface="+mn-lt"/>
+              <a:ea typeface="+mn-ea"/>
+              <a:cs typeface="+mn-cs"/>
+            </a:endParaRPr>
+          </a:p>
+          <a:p>
+            <a:r>
+              <a:rPr lang="en-US" sz="1200" b="0" i="0" kern="1200" dirty="0">
+                <a:solidFill>
+                  <a:schemeClr val="tx1"/>
+                </a:solidFill>
+                <a:effectLst/>
+                <a:latin typeface="+mn-lt"/>
+                <a:ea typeface="+mn-ea"/>
+                <a:cs typeface="+mn-cs"/>
+              </a:rPr>
+              <a:t>Notice the striking pattern: every single red bar collapses straight down into green, ending up at or below zero.</a:t>
+            </a:r>
+          </a:p>
+          <a:p>
+            <a:r>
+              <a:rPr lang="en-US" sz="1200" b="0" i="0" kern="1200" dirty="0">
+                <a:solidFill>
+                  <a:schemeClr val="tx1"/>
+                </a:solidFill>
+                <a:effectLst/>
+                <a:latin typeface="+mn-lt"/>
+                <a:ea typeface="+mn-ea"/>
+                <a:cs typeface="+mn-cs"/>
+              </a:rPr>
+              <a:t>Let us walk through the three cards on the right.</a:t>
+            </a:r>
+          </a:p>
+          <a:p>
+            <a:endParaRPr lang="en-US" sz="1200" b="0" i="0" kern="1200" dirty="0">
+              <a:solidFill>
+                <a:schemeClr val="tx1"/>
+              </a:solidFill>
+              <a:effectLst/>
+              <a:latin typeface="+mn-lt"/>
+              <a:ea typeface="+mn-ea"/>
+              <a:cs typeface="+mn-cs"/>
+            </a:endParaRPr>
+          </a:p>
+          <a:p>
+            <a:r>
+              <a:rPr lang="en-US" sz="1200" b="0" i="0" kern="1200" dirty="0">
+                <a:solidFill>
+                  <a:schemeClr val="tx1"/>
+                </a:solidFill>
+                <a:effectLst/>
+                <a:latin typeface="+mn-lt"/>
+                <a:ea typeface="+mn-ea"/>
+                <a:cs typeface="+mn-cs"/>
+              </a:rPr>
+              <a:t>First, </a:t>
+            </a:r>
+            <a:r>
+              <a:rPr lang="en-US" sz="1200" b="1" i="0" kern="1200" dirty="0">
+                <a:solidFill>
+                  <a:schemeClr val="tx1"/>
+                </a:solidFill>
+                <a:effectLst/>
+                <a:latin typeface="+mn-lt"/>
+                <a:ea typeface="+mn-ea"/>
+                <a:cs typeface="+mn-cs"/>
+              </a:rPr>
+              <a:t>Oracle Leakage</a:t>
+            </a:r>
+            <a:r>
+              <a:rPr lang="en-US" sz="1200" b="0" i="0" kern="1200" dirty="0">
+                <a:solidFill>
+                  <a:schemeClr val="tx1"/>
+                </a:solidFill>
+                <a:effectLst/>
+                <a:latin typeface="+mn-lt"/>
+                <a:ea typeface="+mn-ea"/>
+                <a:cs typeface="+mn-cs"/>
+              </a:rPr>
+              <a:t>. Papers like RCI and </a:t>
+            </a:r>
+            <a:r>
+              <a:rPr lang="en-US" sz="1200" b="0" i="0" kern="1200" dirty="0" err="1">
+                <a:solidFill>
+                  <a:schemeClr val="tx1"/>
+                </a:solidFill>
+                <a:effectLst/>
+                <a:latin typeface="+mn-lt"/>
+                <a:ea typeface="+mn-ea"/>
+                <a:cs typeface="+mn-cs"/>
+              </a:rPr>
+              <a:t>Reflexion</a:t>
+            </a:r>
+            <a:r>
+              <a:rPr lang="en-US" sz="1200" b="0" i="0" kern="1200" dirty="0">
+                <a:solidFill>
+                  <a:schemeClr val="tx1"/>
+                </a:solidFill>
+                <a:effectLst/>
+                <a:latin typeface="+mn-lt"/>
+                <a:ea typeface="+mn-ea"/>
+                <a:cs typeface="+mn-cs"/>
+              </a:rPr>
+              <a:t> reported gains of around 10.5%. But their evaluation harness secretly used ground truth labels to shield correct answers. The model was only prompted to self-correct when its answer was already wrong.</a:t>
+            </a:r>
+          </a:p>
+          <a:p>
+            <a:endParaRPr lang="en-US" sz="1200" b="0" i="1" kern="1200" dirty="0">
+              <a:solidFill>
+                <a:schemeClr val="tx1"/>
+              </a:solidFill>
+              <a:effectLst/>
+              <a:latin typeface="+mn-lt"/>
+              <a:ea typeface="+mn-ea"/>
+              <a:cs typeface="+mn-cs"/>
+            </a:endParaRPr>
+          </a:p>
+          <a:p>
+            <a:r>
+              <a:rPr lang="en-US" sz="1200" b="0" i="1" kern="1200" dirty="0">
+                <a:solidFill>
+                  <a:schemeClr val="tx1"/>
+                </a:solidFill>
+                <a:effectLst/>
+                <a:latin typeface="+mn-lt"/>
+                <a:ea typeface="+mn-ea"/>
+                <a:cs typeface="+mn-cs"/>
+              </a:rPr>
+              <a:t>"That is like taking a multiple choice exam where the teacher only taps your desk when you pick the wrong answer and lets you guess again. In real applications, you do not have an oracle. When you prompt the model on all questions, accuracy drops by 2.5%."</a:t>
+            </a:r>
+          </a:p>
+          <a:p>
+            <a:endParaRPr lang="en-US" sz="1200" b="0" i="1" kern="1200" dirty="0">
+              <a:solidFill>
+                <a:schemeClr val="tx1"/>
+              </a:solidFill>
+              <a:effectLst/>
+              <a:latin typeface="+mn-lt"/>
+              <a:ea typeface="+mn-ea"/>
+              <a:cs typeface="+mn-cs"/>
+            </a:endParaRPr>
+          </a:p>
+          <a:p>
+            <a:r>
+              <a:rPr lang="en-US" sz="1200" b="0" i="0" kern="1200" dirty="0">
+                <a:solidFill>
+                  <a:schemeClr val="tx1"/>
+                </a:solidFill>
+                <a:effectLst/>
+                <a:latin typeface="+mn-lt"/>
+                <a:ea typeface="+mn-ea"/>
+                <a:cs typeface="+mn-cs"/>
+              </a:rPr>
+              <a:t>Second, the </a:t>
+            </a:r>
+            <a:r>
+              <a:rPr lang="en-US" sz="1200" b="1" i="0" kern="1200" dirty="0">
+                <a:solidFill>
+                  <a:schemeClr val="tx1"/>
+                </a:solidFill>
+                <a:effectLst/>
+                <a:latin typeface="+mn-lt"/>
+                <a:ea typeface="+mn-ea"/>
+                <a:cs typeface="+mn-cs"/>
+              </a:rPr>
+              <a:t>Compute Gap</a:t>
+            </a:r>
+            <a:r>
+              <a:rPr lang="en-US" sz="1200" b="0" i="0" kern="1200" dirty="0">
+                <a:solidFill>
+                  <a:schemeClr val="tx1"/>
+                </a:solidFill>
+                <a:effectLst/>
+                <a:latin typeface="+mn-lt"/>
+                <a:ea typeface="+mn-ea"/>
+                <a:cs typeface="+mn-cs"/>
+              </a:rPr>
+              <a:t>. Multi-Agent Debate claimed a 4% gain. But running three agents through rounds of debate consumes 6x the token budget. When the authors matched compute by giving single-agent Self-Consistency the exact same number of sample calls, standard majority voting beat debate by 1.5%.</a:t>
+            </a:r>
+          </a:p>
+          <a:p>
+            <a:endParaRPr lang="en-US" sz="1200" b="0" i="0" kern="1200" dirty="0">
+              <a:solidFill>
+                <a:schemeClr val="tx1"/>
+              </a:solidFill>
+              <a:effectLst/>
+              <a:latin typeface="+mn-lt"/>
+              <a:ea typeface="+mn-ea"/>
+              <a:cs typeface="+mn-cs"/>
+            </a:endParaRPr>
+          </a:p>
+          <a:p>
+            <a:r>
+              <a:rPr lang="en-US" sz="1200" b="0" i="0" kern="1200" dirty="0">
+                <a:solidFill>
+                  <a:schemeClr val="tx1"/>
+                </a:solidFill>
+                <a:effectLst/>
+                <a:latin typeface="+mn-lt"/>
+                <a:ea typeface="+mn-ea"/>
+                <a:cs typeface="+mn-cs"/>
+              </a:rPr>
+              <a:t>Third, the </a:t>
+            </a:r>
+            <a:r>
+              <a:rPr lang="en-US" sz="1200" b="1" i="0" kern="1200" dirty="0">
+                <a:solidFill>
+                  <a:schemeClr val="tx1"/>
+                </a:solidFill>
+                <a:effectLst/>
+                <a:latin typeface="+mn-lt"/>
+                <a:ea typeface="+mn-ea"/>
+                <a:cs typeface="+mn-cs"/>
+              </a:rPr>
+              <a:t>Prompt Trick</a:t>
+            </a:r>
+            <a:r>
+              <a:rPr lang="en-US" sz="1200" b="0" i="0" kern="1200" dirty="0">
+                <a:solidFill>
+                  <a:schemeClr val="tx1"/>
+                </a:solidFill>
+                <a:effectLst/>
+                <a:latin typeface="+mn-lt"/>
+                <a:ea typeface="+mn-ea"/>
+                <a:cs typeface="+mn-cs"/>
+              </a:rPr>
+              <a:t>. Self-Refine reported a 10% gain. However, the initial prompt omitted critical formatting rules, which were only introduced in the feedback prompt. When you provide the complete prompt from the start, the self-correction gain drops to exactly 0.0%.</a:t>
             </a:r>
           </a:p>
         </p:txBody>
@@ -28405,7 +29339,7 @@
         </p:nvSpPr>
         <p:spPr>
           <a:xfrm>
-            <a:off x="548640" y="3246120"/>
+            <a:off x="548640" y="3252426"/>
             <a:ext cx="8046720" cy="1234440"/>
           </a:xfrm>
           <a:prstGeom prst="roundRect">
@@ -28811,7 +29745,7 @@
                 <a:ea typeface="Calibri" pitchFamily="34" charset="-122"/>
                 <a:cs typeface="Calibri" pitchFamily="34" charset="-120"/>
               </a:rPr>
-              <a:t>Rules withheld</a:t>
+              <a:t>Rules omitted</a:t>
             </a:r>
             <a:endParaRPr lang="en-US" sz="1200" dirty="0"/>
           </a:p>

</xml_diff>